<commit_message>
Demos, scenarios and walkthroughs for the new tools and checks
- Demos: reports (CPU spent collecting garbage), deploy (a fix deployed
  but never loaded, a process in old code), dist (a node flooding the
  link to another), and the Elixir bandit_shop (a Bandit API out of
  connections).
- Scenarios 13, 14, 15, 18 and 20, the rest renumbered; walkthroughs 14
  to 18, recorded from sessions given only the symptom.
- CI smoke-tests the release against the deploy and dist demos, and the
  smoke test fails when a diagnose check errors.
- The 15-minute talk counts 26 scenarios.

Co-Authored-By: Claude Opus 5.5 <noreply@anthropic.com>
</commit_message>
<xml_diff>
--- a/talks/three-scenarios.pptx
+++ b/talks/three-scenarios.pptx
@@ -120,39 +120,39 @@
   <p:extLst>
     <p:ext uri="{521415D9-36F7-43E2-AB2F-B90AF26B5E84}">
       <p14:sectionLst xmlns:p14="http://schemas.microsoft.com/office/powerpoint/2010/main">
-        <p14:section name="Opening" id="{381154a1-4574-5bfc-85ff-6f79c67b00dc}">
+        <p14:section name="Opening" id="{4ca635b4-aa48-4657-5ab3-b0769f818853}">
           <p14:sldIdLst>
             <p14:sldId id="256"/>
           </p14:sldIdLst>
         </p14:section>
-        <p14:section name="The tool" id="{47716cb5-19f0-3733-5c47-6ddbdc702fed}">
+        <p14:section name="The tool" id="{5b10f311-0095-cf12-0c88-68ee6cd784ea}">
           <p14:sldIdLst>
             <p14:sldId id="257"/>
             <p14:sldId id="258"/>
           </p14:sldIdLst>
         </p14:section>
-        <p14:section name="Scenario 1" id="{4ff08510-429d-c2d8-4618-867667be231b}">
+        <p14:section name="Scenario 1" id="{5111b3e7-8a1f-b037-7497-409b007a2ee7}">
           <p14:sldIdLst>
             <p14:sldId id="259"/>
             <p14:sldId id="260"/>
             <p14:sldId id="261"/>
           </p14:sldIdLst>
         </p14:section>
-        <p14:section name="Scenario 2" id="{a56262cb-3514-4dee-6c23-51d6af5e65b6}">
+        <p14:section name="Scenario 2" id="{015fc211-c264-1733-766c-eef6ce194a33}">
           <p14:sldIdLst>
             <p14:sldId id="262"/>
             <p14:sldId id="263"/>
             <p14:sldId id="264"/>
           </p14:sldIdLst>
         </p14:section>
-        <p14:section name="Scenario 3" id="{d64c55e9-dedc-0f6f-6b5c-2bfe0a2f1797}">
+        <p14:section name="Scenario 3" id="{0b4d17a2-a804-f197-50b8-db7b2560b149}">
           <p14:sldIdLst>
             <p14:sldId id="265"/>
             <p14:sldId id="266"/>
             <p14:sldId id="267"/>
           </p14:sldIdLst>
         </p14:section>
-        <p14:section name="Closing" id="{52e7b76a-5381-35b2-0c7f-38405d37190d}">
+        <p14:section name="Closing" id="{cf8b3b8e-8c66-1c73-a2a8-f164bfec8d0c}">
           <p14:sldIdLst>
             <p14:sldId id="268"/>
             <p14:sldId id="269"/>
@@ -1002,7 +1002,7 @@
           <a:p>
             <a:r>
               <a:rPr lang="en-US" dirty="0"/>
-              <a:t>All three are demos in the repository, one command each. Start one, point an agent at it with only the symptom, and watch what it does. docs/scenarios.md has all 21 scenarios, and docs/walkthroughs.md has these sessions recorded, every tool call with its real result. Thank you.</a:t>
+              <a:t>All three are demos in the repository, one command each. Start one, point an agent at it with only the symptom, and watch what it does. docs/scenarios.md has all 26 scenarios, and docs/walkthroughs.md has these sessions recorded, every tool call with its real result. Thank you.</a:t>
             </a:r>
             <a:endParaRPr lang="en-US" dirty="0"/>
           </a:p>
@@ -5481,7 +5481,7 @@
       </p:sp>
       <p:sp>
         <p:nvSpPr>
-          <p:cNvPr id="9" name="All 21 scenarios circle"/>
+          <p:cNvPr id="9" name="All 26 scenarios circle"/>
           <p:cNvSpPr/>
           <p:nvPr/>
         </p:nvSpPr>
@@ -5506,7 +5506,7 @@
       </p:sp>
       <p:pic>
         <p:nvPicPr>
-          <p:cNvPr id="10" name="All 21 scenarios icon" descr="All 21 scenarios">    </p:cNvPr>
+          <p:cNvPr id="10" name="All 26 scenarios icon" descr="All 26 scenarios">    </p:cNvPr>
           <p:cNvPicPr>
             <a:picLocks noChangeAspect="1"/>
           </p:cNvPicPr>
@@ -5561,7 +5561,7 @@
                 <a:ea typeface="Calibri" pitchFamily="34" charset="-122"/>
                 <a:cs typeface="Calibri" pitchFamily="34" charset="-120"/>
               </a:rPr>
-              <a:t>All 21 scenarios</a:t>
+              <a:t>All 26 scenarios</a:t>
             </a:r>
             <a:endParaRPr lang="en-US" sz="1500" dirty="0"/>
           </a:p>

</xml_diff>

<commit_message>
A riak_core demo, scenario 16 and walkthrough 19
examples/elixir/run.sh riak forms a three-node shop cluster, takes
riak_c down and swamps a vnode with a flash sale's hot key. Scenario 16
covers riak_core clusters, the later ones renumbered; walkthrough 19 is
a session given only the symptom.

Co-Authored-By: Claude Opus 5.5 <noreply@anthropic.com>
</commit_message>
<xml_diff>
--- a/talks/three-scenarios.pptx
+++ b/talks/three-scenarios.pptx
@@ -120,39 +120,39 @@
   <p:extLst>
     <p:ext uri="{521415D9-36F7-43E2-AB2F-B90AF26B5E84}">
       <p14:sectionLst xmlns:p14="http://schemas.microsoft.com/office/powerpoint/2010/main">
-        <p14:section name="Opening" id="{4ca635b4-aa48-4657-5ab3-b0769f818853}">
+        <p14:section name="Opening" id="{e578f95f-3d96-c6b1-2202-04ce1e9810b6}">
           <p14:sldIdLst>
             <p14:sldId id="256"/>
           </p14:sldIdLst>
         </p14:section>
-        <p14:section name="The tool" id="{5b10f311-0095-cf12-0c88-68ee6cd784ea}">
+        <p14:section name="The tool" id="{d4ac0244-4c3a-c486-3355-472284ec1260}">
           <p14:sldIdLst>
             <p14:sldId id="257"/>
             <p14:sldId id="258"/>
           </p14:sldIdLst>
         </p14:section>
-        <p14:section name="Scenario 1" id="{5111b3e7-8a1f-b037-7497-409b007a2ee7}">
+        <p14:section name="Scenario 1" id="{26896479-3b85-672d-7923-e2d8dd854b26}">
           <p14:sldIdLst>
             <p14:sldId id="259"/>
             <p14:sldId id="260"/>
             <p14:sldId id="261"/>
           </p14:sldIdLst>
         </p14:section>
-        <p14:section name="Scenario 2" id="{015fc211-c264-1733-766c-eef6ce194a33}">
+        <p14:section name="Scenario 2" id="{df665ae1-864e-95f2-0535-eb294c765876}">
           <p14:sldIdLst>
             <p14:sldId id="262"/>
             <p14:sldId id="263"/>
             <p14:sldId id="264"/>
           </p14:sldIdLst>
         </p14:section>
-        <p14:section name="Scenario 3" id="{0b4d17a2-a804-f197-50b8-db7b2560b149}">
+        <p14:section name="Scenario 3" id="{037fb4aa-66fa-1af2-03fe-e764a138a3ed}">
           <p14:sldIdLst>
             <p14:sldId id="265"/>
             <p14:sldId id="266"/>
             <p14:sldId id="267"/>
           </p14:sldIdLst>
         </p14:section>
-        <p14:section name="Closing" id="{cf8b3b8e-8c66-1c73-a2a8-f164bfec8d0c}">
+        <p14:section name="Closing" id="{361826ea-fae0-01fe-0e20-48ed84df165f}">
           <p14:sldIdLst>
             <p14:sldId id="268"/>
             <p14:sldId id="269"/>
@@ -1002,7 +1002,7 @@
           <a:p>
             <a:r>
               <a:rPr lang="en-US" dirty="0"/>
-              <a:t>All three are demos in the repository, one command each. Start one, point an agent at it with only the symptom, and watch what it does. docs/scenarios.md has all 26 scenarios, and docs/walkthroughs.md has these sessions recorded, every tool call with its real result. Thank you.</a:t>
+              <a:t>All three are demos in the repository, one command each. Start one, point an agent at it with only the symptom, and watch what it does. docs/scenarios.md has all 27 scenarios, and docs/walkthroughs.md has these sessions recorded, every tool call with its real result. Thank you.</a:t>
             </a:r>
             <a:endParaRPr lang="en-US" dirty="0"/>
           </a:p>
@@ -5481,7 +5481,7 @@
       </p:sp>
       <p:sp>
         <p:nvSpPr>
-          <p:cNvPr id="9" name="All 26 scenarios circle"/>
+          <p:cNvPr id="9" name="All 27 scenarios circle"/>
           <p:cNvSpPr/>
           <p:nvPr/>
         </p:nvSpPr>
@@ -5506,7 +5506,7 @@
       </p:sp>
       <p:pic>
         <p:nvPicPr>
-          <p:cNvPr id="10" name="All 26 scenarios icon" descr="All 26 scenarios">    </p:cNvPr>
+          <p:cNvPr id="10" name="All 27 scenarios icon" descr="All 27 scenarios">    </p:cNvPr>
           <p:cNvPicPr>
             <a:picLocks noChangeAspect="1"/>
           </p:cNvPicPr>
@@ -5561,7 +5561,7 @@
                 <a:ea typeface="Calibri" pitchFamily="34" charset="-122"/>
                 <a:cs typeface="Calibri" pitchFamily="34" charset="-120"/>
               </a:rPr>
-              <a:t>All 26 scenarios</a:t>
+              <a:t>All 27 scenarios</a:t>
             </a:r>
             <a:endParaRPr lang="en-US" sz="1500" dirty="0"/>
           </a:p>

</xml_diff>